<commit_message>
Personalbeschaffung thumbnail: new background and neutral headline
Co-Authored-By: Claude Sonnet 5.5 <noreply@anthropic.com>
Claude-Session: https://claude.ai/code/session_0139kriXJ67p3UvpR2gsSR9G
</commit_message>
<xml_diff>
--- a/videoslides/cleverbox-thumbnail-personalbeschaffung.pptx
+++ b/videoslides/cleverbox-thumbnail-personalbeschaffung.pptx
@@ -997,12 +997,12 @@
         </p:nvSpPr>
         <p:spPr>
           <a:xfrm>
-            <a:off x="5610225" y="4095750"/>
-            <a:ext cx="4324350" cy="942975"/>
+            <a:off x="5610225" y="4210050"/>
+            <a:ext cx="4391025" cy="1123950"/>
           </a:xfrm>
           <a:prstGeom prst="roundRect">
             <a:avLst>
-              <a:gd name="adj" fmla="val 17455"/>
+              <a:gd name="adj" fmla="val 14644"/>
             </a:avLst>
           </a:prstGeom>
           <a:solidFill>
@@ -1024,8 +1024,8 @@
         </p:nvSpPr>
         <p:spPr>
           <a:xfrm>
-            <a:off x="5762625" y="1914525"/>
-            <a:ext cx="6286500" cy="1047750"/>
+            <a:off x="5762625" y="1609725"/>
+            <a:ext cx="6286500" cy="1247775"/>
           </a:xfrm>
           <a:prstGeom prst="rect">
             <a:avLst/>
@@ -1041,7 +1041,7 @@
               <a:buNone/>
             </a:pPr>
             <a:r>
-              <a:rPr lang="en-US" sz="6600" b="1" i="1" dirty="0">
+              <a:rPr lang="en-US" sz="7800" b="1" i="1" dirty="0">
                 <a:solidFill>
                   <a:srgbClr val="0F3A40"/>
                 </a:solidFill>
@@ -1049,9 +1049,9 @@
                 <a:ea typeface="Poppins" pitchFamily="34" charset="-122"/>
                 <a:cs typeface="Poppins" pitchFamily="34" charset="-120"/>
               </a:rPr>
-              <a:t>DIE RICHTIGE</a:t>
+              <a:t>PERSONAL</a:t>
             </a:r>
-            <a:endParaRPr lang="en-US" sz="6600" dirty="0"/>
+            <a:endParaRPr lang="en-US" sz="7800" dirty="0"/>
           </a:p>
         </p:txBody>
       </p:sp>
@@ -1063,8 +1063,8 @@
         </p:nvSpPr>
         <p:spPr>
           <a:xfrm>
-            <a:off x="5762625" y="2962275"/>
-            <a:ext cx="6286500" cy="1047750"/>
+            <a:off x="5762625" y="2857500"/>
+            <a:ext cx="6286500" cy="1247775"/>
           </a:xfrm>
           <a:prstGeom prst="rect">
             <a:avLst/>
@@ -1080,7 +1080,7 @@
               <a:buNone/>
             </a:pPr>
             <a:r>
-              <a:rPr lang="en-US" sz="6600" b="1" i="1" dirty="0">
+              <a:rPr lang="en-US" sz="7800" b="1" i="1" dirty="0">
                 <a:solidFill>
                   <a:srgbClr val="0F3A40"/>
                 </a:solidFill>
@@ -1088,9 +1088,9 @@
                 <a:ea typeface="Poppins" pitchFamily="34" charset="-122"/>
                 <a:cs typeface="Poppins" pitchFamily="34" charset="-120"/>
               </a:rPr>
-              <a:t>PERSON</a:t>
+              <a:t>SUCHEN &amp;</a:t>
             </a:r>
-            <a:endParaRPr lang="en-US" sz="6600" dirty="0"/>
+            <a:endParaRPr lang="en-US" sz="7800" dirty="0"/>
           </a:p>
         </p:txBody>
       </p:sp>
@@ -1102,8 +1102,8 @@
         </p:nvSpPr>
         <p:spPr>
           <a:xfrm>
-            <a:off x="5762625" y="4010025"/>
-            <a:ext cx="6286500" cy="1047750"/>
+            <a:off x="5762625" y="4105275"/>
+            <a:ext cx="6286500" cy="1247775"/>
           </a:xfrm>
           <a:prstGeom prst="rect">
             <a:avLst/>
@@ -1119,7 +1119,7 @@
               <a:buNone/>
             </a:pPr>
             <a:r>
-              <a:rPr lang="en-US" sz="6600" b="1" i="1" dirty="0">
+              <a:rPr lang="en-US" sz="7800" b="1" i="1" dirty="0">
                 <a:solidFill>
                   <a:srgbClr val="0F3A40"/>
                 </a:solidFill>
@@ -1127,9 +1127,9 @@
                 <a:ea typeface="Poppins" pitchFamily="34" charset="-122"/>
                 <a:cs typeface="Poppins" pitchFamily="34" charset="-120"/>
               </a:rPr>
-              <a:t>FINDEN?</a:t>
+              <a:t>FINDEN</a:t>
             </a:r>
-            <a:endParaRPr lang="en-US" sz="6600" dirty="0"/>
+            <a:endParaRPr lang="en-US" sz="7800" dirty="0"/>
           </a:p>
         </p:txBody>
       </p:sp>
@@ -1141,7 +1141,7 @@
         </p:nvSpPr>
         <p:spPr>
           <a:xfrm>
-            <a:off x="5762625" y="5191125"/>
+            <a:off x="5762625" y="5486400"/>
             <a:ext cx="1181100" cy="495300"/>
           </a:xfrm>
           <a:prstGeom prst="roundRect">
@@ -1168,7 +1168,7 @@
         </p:nvSpPr>
         <p:spPr>
           <a:xfrm>
-            <a:off x="5762625" y="5191125"/>
+            <a:off x="5762625" y="5486400"/>
             <a:ext cx="1181100" cy="495300"/>
           </a:xfrm>
           <a:prstGeom prst="rect">
@@ -1207,7 +1207,7 @@
         </p:nvSpPr>
         <p:spPr>
           <a:xfrm>
-            <a:off x="7060109" y="5191125"/>
+            <a:off x="7060109" y="5486400"/>
             <a:ext cx="1371600" cy="495300"/>
           </a:xfrm>
           <a:prstGeom prst="roundRect">
@@ -1234,7 +1234,7 @@
         </p:nvSpPr>
         <p:spPr>
           <a:xfrm>
-            <a:off x="7060109" y="5191125"/>
+            <a:off x="7060109" y="5486400"/>
             <a:ext cx="1371600" cy="495300"/>
           </a:xfrm>
           <a:prstGeom prst="rect">
@@ -1273,7 +1273,7 @@
         </p:nvSpPr>
         <p:spPr>
           <a:xfrm>
-            <a:off x="8550473" y="5191125"/>
+            <a:off x="8550473" y="5486400"/>
             <a:ext cx="1800225" cy="495300"/>
           </a:xfrm>
           <a:prstGeom prst="roundRect">
@@ -1300,7 +1300,7 @@
         </p:nvSpPr>
         <p:spPr>
           <a:xfrm>
-            <a:off x="8550473" y="5191125"/>
+            <a:off x="8550473" y="5486400"/>
             <a:ext cx="1800225" cy="495300"/>
           </a:xfrm>
           <a:prstGeom prst="rect">
@@ -1339,7 +1339,7 @@
         </p:nvSpPr>
         <p:spPr>
           <a:xfrm>
-            <a:off x="10465147" y="5191125"/>
+            <a:off x="10465147" y="5486400"/>
             <a:ext cx="1285875" cy="495300"/>
           </a:xfrm>
           <a:prstGeom prst="roundRect">
@@ -1366,7 +1366,7 @@
         </p:nvSpPr>
         <p:spPr>
           <a:xfrm>
-            <a:off x="10465147" y="5191125"/>
+            <a:off x="10465147" y="5486400"/>
             <a:ext cx="1285875" cy="495300"/>
           </a:xfrm>
           <a:prstGeom prst="rect">

</xml_diff>